<commit_message>
Set out chapter 5 approach in week 40 slides; drop unused decks
Chapter 5 now walks through the GGM workflow step by step, asking the same
four questions of each step, and ends with a summary figure and a job
description per agent. Removes the week 38 notes deck and the short week 39
structure deck, which are no longer needed.

Co-Authored-By: Claude Opus 5.5 <noreply@anthropic.com>
</commit_message>
<xml_diff>
--- a/supervisor-meetings/week40-project-thesis-structure.pptx
+++ b/supervisor-meetings/week40-project-thesis-structure.pptx
@@ -717,7 +717,7 @@
           <a:lstStyle/>
           <a:p>
             <a:r>
-              <a:t>Nothing to present here yet. We are giving ourselves some time to work out the approach.</a:t>
+              <a:t>The chapter follows the workflow step by step, and every step gets the same four questions. We keep it general so it holds for any GGM setup, and use short examples from the 2023 data as evidence. It ends with a figure that sums it up, whose format we haven't settled, and a job description for each agent, which is where next semester starts.</a:t>
             </a:r>
           </a:p>
         </p:txBody>
@@ -7425,35 +7425,74 @@
                 </a:solidFill>
                 <a:latin typeface="Calibri"/>
               </a:rPr>
-              <a:t>The core of the thesis. This is where we map out how and where AI could be used, and what that means for next semester.</a:t>
-            </a:r>
-          </a:p>
-        </p:txBody>
-      </p:sp>
-      <p:sp>
-        <p:nvSpPr>
-          <p:cNvPr id="4" name="Rounded Rectangle 3"/>
+              <a:t>The core of the thesis. We walk through the GGM workflow in the order the work happens, and look at where AI could help at each step.</a:t>
+            </a:r>
+          </a:p>
+        </p:txBody>
+      </p:sp>
+      <p:sp>
+        <p:nvSpPr>
+          <p:cNvPr id="4" name="TextBox 3"/>
+          <p:cNvSpPr txBox="1"/>
+          <p:nvPr/>
+        </p:nvSpPr>
+        <p:spPr>
+          <a:xfrm>
+            <a:off x="640080" y="1719072"/>
+            <a:ext cx="10911535" cy="274320"/>
+          </a:xfrm>
+          <a:prstGeom prst="rect">
+            <a:avLst/>
+          </a:prstGeom>
+          <a:noFill/>
+        </p:spPr>
+        <p:txBody>
+          <a:bodyPr wrap="square" lIns="0" rIns="0" tIns="0" bIns="0" anchor="t">
+            <a:spAutoFit/>
+          </a:bodyPr>
+          <a:lstStyle/>
+          <a:p>
+            <a:pPr algn="l">
+              <a:lnSpc>
+                <a:spcPts val="1689"/>
+              </a:lnSpc>
+              <a:spcAft>
+                <a:spcPts val="0"/>
+              </a:spcAft>
+            </a:pPr>
+            <a:r>
+              <a:rPr sz="1350" b="1" i="0">
+                <a:solidFill>
+                  <a:srgbClr val="5B6770"/>
+                </a:solidFill>
+                <a:latin typeface="Calibri"/>
+              </a:rPr>
+              <a:t>The steps we go through</a:t>
+            </a:r>
+          </a:p>
+        </p:txBody>
+      </p:sp>
+      <p:sp>
+        <p:nvSpPr>
+          <p:cNvPr id="5" name="Rounded Rectangle 4"/>
           <p:cNvSpPr/>
           <p:nvPr/>
         </p:nvSpPr>
         <p:spPr>
           <a:xfrm>
-            <a:off x="640080" y="1920240"/>
-            <a:ext cx="10911535" cy="1463040"/>
+            <a:off x="640080" y="2057400"/>
+            <a:ext cx="1513789" cy="777240"/>
           </a:xfrm>
           <a:prstGeom prst="roundRect">
             <a:avLst>
-              <a:gd name="adj" fmla="val 8000"/>
+              <a:gd name="adj" fmla="val 12000"/>
             </a:avLst>
           </a:prstGeom>
           <a:solidFill>
-            <a:srgbClr val="FBEEDD"/>
+            <a:srgbClr val="EAF0F4"/>
           </a:solidFill>
-          <a:ln w="19050">
-            <a:solidFill>
-              <a:srgbClr val="D9822B"/>
-            </a:solidFill>
-            <a:prstDash val="dash"/>
+          <a:ln>
+            <a:noFill/>
           </a:ln>
           <a:effectLst/>
         </p:spPr>
@@ -7481,14 +7520,14 @@
       </p:sp>
       <p:sp>
         <p:nvSpPr>
-          <p:cNvPr id="5" name="TextBox 4"/>
+          <p:cNvPr id="6" name="TextBox 5"/>
           <p:cNvSpPr txBox="1"/>
           <p:nvPr/>
         </p:nvSpPr>
         <p:spPr>
           <a:xfrm>
-            <a:off x="1051560" y="1920240"/>
-            <a:ext cx="10088575" cy="1463040"/>
+            <a:off x="731519" y="2057400"/>
+            <a:ext cx="1330909" cy="777240"/>
           </a:xfrm>
           <a:prstGeom prst="rect">
             <a:avLst/>
@@ -7501,41 +7540,1612 @@
           </a:bodyPr>
           <a:lstStyle/>
           <a:p>
+            <a:pPr algn="ctr">
+              <a:lnSpc>
+                <a:spcPts val="1600"/>
+              </a:lnSpc>
+              <a:spcAft>
+                <a:spcPts val="0"/>
+              </a:spcAft>
+            </a:pPr>
+            <a:r>
+              <a:rPr sz="1350" b="1" i="0">
+                <a:solidFill>
+                  <a:srgbClr val="1F5673"/>
+                </a:solidFill>
+                <a:latin typeface="Calibri"/>
+              </a:rPr>
+              <a:t>Get source data</a:t>
+            </a:r>
+          </a:p>
+        </p:txBody>
+      </p:sp>
+      <p:sp>
+        <p:nvSpPr>
+          <p:cNvPr id="7" name="Right Arrow 6"/>
+          <p:cNvSpPr/>
+          <p:nvPr/>
+        </p:nvSpPr>
+        <p:spPr>
+          <a:xfrm>
+            <a:off x="2199589" y="2327148"/>
+            <a:ext cx="274320" cy="237744"/>
+          </a:xfrm>
+          <a:prstGeom prst="rightArrow">
+            <a:avLst/>
+          </a:prstGeom>
+          <a:solidFill>
+            <a:srgbClr val="8DB0C4"/>
+          </a:solidFill>
+          <a:ln>
+            <a:noFill/>
+          </a:ln>
+          <a:effectLst/>
+        </p:spPr>
+        <p:style>
+          <a:lnRef idx="1">
+            <a:schemeClr val="accent1"/>
+          </a:lnRef>
+          <a:fillRef idx="3">
+            <a:schemeClr val="accent1"/>
+          </a:fillRef>
+          <a:effectRef idx="2">
+            <a:schemeClr val="accent1"/>
+          </a:effectRef>
+          <a:fontRef idx="minor">
+            <a:schemeClr val="lt1"/>
+          </a:fontRef>
+        </p:style>
+        <p:txBody>
+          <a:bodyPr rtlCol="0" anchor="ctr"/>
+          <a:lstStyle/>
+          <a:p>
+            <a:pPr algn="ctr"/>
+          </a:p>
+        </p:txBody>
+      </p:sp>
+      <p:sp>
+        <p:nvSpPr>
+          <p:cNvPr id="8" name="Rounded Rectangle 7"/>
+          <p:cNvSpPr/>
+          <p:nvPr/>
+        </p:nvSpPr>
+        <p:spPr>
+          <a:xfrm>
+            <a:off x="2519629" y="2057400"/>
+            <a:ext cx="1513789" cy="777240"/>
+          </a:xfrm>
+          <a:prstGeom prst="roundRect">
+            <a:avLst>
+              <a:gd name="adj" fmla="val 12000"/>
+            </a:avLst>
+          </a:prstGeom>
+          <a:solidFill>
+            <a:srgbClr val="EAF0F4"/>
+          </a:solidFill>
+          <a:ln>
+            <a:noFill/>
+          </a:ln>
+          <a:effectLst/>
+        </p:spPr>
+        <p:style>
+          <a:lnRef idx="1">
+            <a:schemeClr val="accent1"/>
+          </a:lnRef>
+          <a:fillRef idx="3">
+            <a:schemeClr val="accent1"/>
+          </a:fillRef>
+          <a:effectRef idx="2">
+            <a:schemeClr val="accent1"/>
+          </a:effectRef>
+          <a:fontRef idx="minor">
+            <a:schemeClr val="lt1"/>
+          </a:fontRef>
+        </p:style>
+        <p:txBody>
+          <a:bodyPr rtlCol="0" anchor="ctr"/>
+          <a:lstStyle/>
+          <a:p>
+            <a:pPr algn="ctr"/>
+          </a:p>
+        </p:txBody>
+      </p:sp>
+      <p:sp>
+        <p:nvSpPr>
+          <p:cNvPr id="9" name="TextBox 8"/>
+          <p:cNvSpPr txBox="1"/>
+          <p:nvPr/>
+        </p:nvSpPr>
+        <p:spPr>
+          <a:xfrm>
+            <a:off x="2611069" y="2057400"/>
+            <a:ext cx="1330909" cy="777240"/>
+          </a:xfrm>
+          <a:prstGeom prst="rect">
+            <a:avLst/>
+          </a:prstGeom>
+          <a:noFill/>
+        </p:spPr>
+        <p:txBody>
+          <a:bodyPr wrap="square" lIns="0" rIns="0" tIns="0" bIns="0" anchor="ctr">
+            <a:spAutoFit/>
+          </a:bodyPr>
+          <a:lstStyle/>
+          <a:p>
+            <a:pPr algn="ctr">
+              <a:lnSpc>
+                <a:spcPts val="1600"/>
+              </a:lnSpc>
+              <a:spcAft>
+                <a:spcPts val="0"/>
+              </a:spcAft>
+            </a:pPr>
+            <a:r>
+              <a:rPr sz="1350" b="1" i="0">
+                <a:solidFill>
+                  <a:srgbClr val="1F5673"/>
+                </a:solidFill>
+                <a:latin typeface="Calibri"/>
+              </a:rPr>
+              <a:t>Prepare the data</a:t>
+            </a:r>
+          </a:p>
+        </p:txBody>
+      </p:sp>
+      <p:sp>
+        <p:nvSpPr>
+          <p:cNvPr id="10" name="Right Arrow 9"/>
+          <p:cNvSpPr/>
+          <p:nvPr/>
+        </p:nvSpPr>
+        <p:spPr>
+          <a:xfrm>
+            <a:off x="4079138" y="2327148"/>
+            <a:ext cx="274320" cy="237744"/>
+          </a:xfrm>
+          <a:prstGeom prst="rightArrow">
+            <a:avLst/>
+          </a:prstGeom>
+          <a:solidFill>
+            <a:srgbClr val="8DB0C4"/>
+          </a:solidFill>
+          <a:ln>
+            <a:noFill/>
+          </a:ln>
+          <a:effectLst/>
+        </p:spPr>
+        <p:style>
+          <a:lnRef idx="1">
+            <a:schemeClr val="accent1"/>
+          </a:lnRef>
+          <a:fillRef idx="3">
+            <a:schemeClr val="accent1"/>
+          </a:fillRef>
+          <a:effectRef idx="2">
+            <a:schemeClr val="accent1"/>
+          </a:effectRef>
+          <a:fontRef idx="minor">
+            <a:schemeClr val="lt1"/>
+          </a:fontRef>
+        </p:style>
+        <p:txBody>
+          <a:bodyPr rtlCol="0" anchor="ctr"/>
+          <a:lstStyle/>
+          <a:p>
+            <a:pPr algn="ctr"/>
+          </a:p>
+        </p:txBody>
+      </p:sp>
+      <p:sp>
+        <p:nvSpPr>
+          <p:cNvPr id="11" name="Rounded Rectangle 10"/>
+          <p:cNvSpPr/>
+          <p:nvPr/>
+        </p:nvSpPr>
+        <p:spPr>
+          <a:xfrm>
+            <a:off x="4399178" y="2057400"/>
+            <a:ext cx="1513789" cy="777240"/>
+          </a:xfrm>
+          <a:prstGeom prst="roundRect">
+            <a:avLst>
+              <a:gd name="adj" fmla="val 12000"/>
+            </a:avLst>
+          </a:prstGeom>
+          <a:solidFill>
+            <a:srgbClr val="EAF0F4"/>
+          </a:solidFill>
+          <a:ln>
+            <a:noFill/>
+          </a:ln>
+          <a:effectLst/>
+        </p:spPr>
+        <p:style>
+          <a:lnRef idx="1">
+            <a:schemeClr val="accent1"/>
+          </a:lnRef>
+          <a:fillRef idx="3">
+            <a:schemeClr val="accent1"/>
+          </a:fillRef>
+          <a:effectRef idx="2">
+            <a:schemeClr val="accent1"/>
+          </a:effectRef>
+          <a:fontRef idx="minor">
+            <a:schemeClr val="lt1"/>
+          </a:fontRef>
+        </p:style>
+        <p:txBody>
+          <a:bodyPr rtlCol="0" anchor="ctr"/>
+          <a:lstStyle/>
+          <a:p>
+            <a:pPr algn="ctr"/>
+          </a:p>
+        </p:txBody>
+      </p:sp>
+      <p:sp>
+        <p:nvSpPr>
+          <p:cNvPr id="12" name="TextBox 11"/>
+          <p:cNvSpPr txBox="1"/>
+          <p:nvPr/>
+        </p:nvSpPr>
+        <p:spPr>
+          <a:xfrm>
+            <a:off x="4490618" y="2057400"/>
+            <a:ext cx="1330909" cy="777240"/>
+          </a:xfrm>
+          <a:prstGeom prst="rect">
+            <a:avLst/>
+          </a:prstGeom>
+          <a:noFill/>
+        </p:spPr>
+        <p:txBody>
+          <a:bodyPr wrap="square" lIns="0" rIns="0" tIns="0" bIns="0" anchor="ctr">
+            <a:spAutoFit/>
+          </a:bodyPr>
+          <a:lstStyle/>
+          <a:p>
+            <a:pPr algn="ctr">
+              <a:lnSpc>
+                <a:spcPts val="1600"/>
+              </a:lnSpc>
+              <a:spcAft>
+                <a:spcPts val="0"/>
+              </a:spcAft>
+            </a:pPr>
+            <a:r>
+              <a:rPr sz="1350" b="1" i="0">
+                <a:solidFill>
+                  <a:srgbClr val="1F5673"/>
+                </a:solidFill>
+                <a:latin typeface="Calibri"/>
+              </a:rPr>
+              <a:t>Set up the scenario</a:t>
+            </a:r>
+          </a:p>
+        </p:txBody>
+      </p:sp>
+      <p:sp>
+        <p:nvSpPr>
+          <p:cNvPr id="13" name="Right Arrow 12"/>
+          <p:cNvSpPr/>
+          <p:nvPr/>
+        </p:nvSpPr>
+        <p:spPr>
+          <a:xfrm>
+            <a:off x="5958687" y="2327148"/>
+            <a:ext cx="274320" cy="237744"/>
+          </a:xfrm>
+          <a:prstGeom prst="rightArrow">
+            <a:avLst/>
+          </a:prstGeom>
+          <a:solidFill>
+            <a:srgbClr val="8DB0C4"/>
+          </a:solidFill>
+          <a:ln>
+            <a:noFill/>
+          </a:ln>
+          <a:effectLst/>
+        </p:spPr>
+        <p:style>
+          <a:lnRef idx="1">
+            <a:schemeClr val="accent1"/>
+          </a:lnRef>
+          <a:fillRef idx="3">
+            <a:schemeClr val="accent1"/>
+          </a:fillRef>
+          <a:effectRef idx="2">
+            <a:schemeClr val="accent1"/>
+          </a:effectRef>
+          <a:fontRef idx="minor">
+            <a:schemeClr val="lt1"/>
+          </a:fontRef>
+        </p:style>
+        <p:txBody>
+          <a:bodyPr rtlCol="0" anchor="ctr"/>
+          <a:lstStyle/>
+          <a:p>
+            <a:pPr algn="ctr"/>
+          </a:p>
+        </p:txBody>
+      </p:sp>
+      <p:sp>
+        <p:nvSpPr>
+          <p:cNvPr id="14" name="Rounded Rectangle 13"/>
+          <p:cNvSpPr/>
+          <p:nvPr/>
+        </p:nvSpPr>
+        <p:spPr>
+          <a:xfrm>
+            <a:off x="6278727" y="2057400"/>
+            <a:ext cx="1513789" cy="777240"/>
+          </a:xfrm>
+          <a:prstGeom prst="roundRect">
+            <a:avLst>
+              <a:gd name="adj" fmla="val 12000"/>
+            </a:avLst>
+          </a:prstGeom>
+          <a:solidFill>
+            <a:srgbClr val="EAF0F4"/>
+          </a:solidFill>
+          <a:ln>
+            <a:noFill/>
+          </a:ln>
+          <a:effectLst/>
+        </p:spPr>
+        <p:style>
+          <a:lnRef idx="1">
+            <a:schemeClr val="accent1"/>
+          </a:lnRef>
+          <a:fillRef idx="3">
+            <a:schemeClr val="accent1"/>
+          </a:fillRef>
+          <a:effectRef idx="2">
+            <a:schemeClr val="accent1"/>
+          </a:effectRef>
+          <a:fontRef idx="minor">
+            <a:schemeClr val="lt1"/>
+          </a:fontRef>
+        </p:style>
+        <p:txBody>
+          <a:bodyPr rtlCol="0" anchor="ctr"/>
+          <a:lstStyle/>
+          <a:p>
+            <a:pPr algn="ctr"/>
+          </a:p>
+        </p:txBody>
+      </p:sp>
+      <p:sp>
+        <p:nvSpPr>
+          <p:cNvPr id="15" name="TextBox 14"/>
+          <p:cNvSpPr txBox="1"/>
+          <p:nvPr/>
+        </p:nvSpPr>
+        <p:spPr>
+          <a:xfrm>
+            <a:off x="6370167" y="2057400"/>
+            <a:ext cx="1330909" cy="777240"/>
+          </a:xfrm>
+          <a:prstGeom prst="rect">
+            <a:avLst/>
+          </a:prstGeom>
+          <a:noFill/>
+        </p:spPr>
+        <p:txBody>
+          <a:bodyPr wrap="square" lIns="0" rIns="0" tIns="0" bIns="0" anchor="ctr">
+            <a:spAutoFit/>
+          </a:bodyPr>
+          <a:lstStyle/>
+          <a:p>
+            <a:pPr algn="ctr">
+              <a:lnSpc>
+                <a:spcPts val="1600"/>
+              </a:lnSpc>
+              <a:spcAft>
+                <a:spcPts val="0"/>
+              </a:spcAft>
+            </a:pPr>
+            <a:r>
+              <a:rPr sz="1350" b="1" i="0">
+                <a:solidFill>
+                  <a:srgbClr val="1F5673"/>
+                </a:solidFill>
+                <a:latin typeface="Calibri"/>
+              </a:rPr>
+              <a:t>Calibrate</a:t>
+            </a:r>
+          </a:p>
+        </p:txBody>
+      </p:sp>
+      <p:sp>
+        <p:nvSpPr>
+          <p:cNvPr id="16" name="Right Arrow 15"/>
+          <p:cNvSpPr/>
+          <p:nvPr/>
+        </p:nvSpPr>
+        <p:spPr>
+          <a:xfrm>
+            <a:off x="7838236" y="2327148"/>
+            <a:ext cx="274320" cy="237744"/>
+          </a:xfrm>
+          <a:prstGeom prst="rightArrow">
+            <a:avLst/>
+          </a:prstGeom>
+          <a:solidFill>
+            <a:srgbClr val="8DB0C4"/>
+          </a:solidFill>
+          <a:ln>
+            <a:noFill/>
+          </a:ln>
+          <a:effectLst/>
+        </p:spPr>
+        <p:style>
+          <a:lnRef idx="1">
+            <a:schemeClr val="accent1"/>
+          </a:lnRef>
+          <a:fillRef idx="3">
+            <a:schemeClr val="accent1"/>
+          </a:fillRef>
+          <a:effectRef idx="2">
+            <a:schemeClr val="accent1"/>
+          </a:effectRef>
+          <a:fontRef idx="minor">
+            <a:schemeClr val="lt1"/>
+          </a:fontRef>
+        </p:style>
+        <p:txBody>
+          <a:bodyPr rtlCol="0" anchor="ctr"/>
+          <a:lstStyle/>
+          <a:p>
+            <a:pPr algn="ctr"/>
+          </a:p>
+        </p:txBody>
+      </p:sp>
+      <p:sp>
+        <p:nvSpPr>
+          <p:cNvPr id="17" name="Rounded Rectangle 16"/>
+          <p:cNvSpPr/>
+          <p:nvPr/>
+        </p:nvSpPr>
+        <p:spPr>
+          <a:xfrm>
+            <a:off x="8158276" y="2057400"/>
+            <a:ext cx="1513789" cy="777240"/>
+          </a:xfrm>
+          <a:prstGeom prst="roundRect">
+            <a:avLst>
+              <a:gd name="adj" fmla="val 12000"/>
+            </a:avLst>
+          </a:prstGeom>
+          <a:solidFill>
+            <a:srgbClr val="EAF0F4"/>
+          </a:solidFill>
+          <a:ln>
+            <a:noFill/>
+          </a:ln>
+          <a:effectLst/>
+        </p:spPr>
+        <p:style>
+          <a:lnRef idx="1">
+            <a:schemeClr val="accent1"/>
+          </a:lnRef>
+          <a:fillRef idx="3">
+            <a:schemeClr val="accent1"/>
+          </a:fillRef>
+          <a:effectRef idx="2">
+            <a:schemeClr val="accent1"/>
+          </a:effectRef>
+          <a:fontRef idx="minor">
+            <a:schemeClr val="lt1"/>
+          </a:fontRef>
+        </p:style>
+        <p:txBody>
+          <a:bodyPr rtlCol="0" anchor="ctr"/>
+          <a:lstStyle/>
+          <a:p>
+            <a:pPr algn="ctr"/>
+          </a:p>
+        </p:txBody>
+      </p:sp>
+      <p:sp>
+        <p:nvSpPr>
+          <p:cNvPr id="18" name="TextBox 17"/>
+          <p:cNvSpPr txBox="1"/>
+          <p:nvPr/>
+        </p:nvSpPr>
+        <p:spPr>
+          <a:xfrm>
+            <a:off x="8249716" y="2057400"/>
+            <a:ext cx="1330909" cy="777240"/>
+          </a:xfrm>
+          <a:prstGeom prst="rect">
+            <a:avLst/>
+          </a:prstGeom>
+          <a:noFill/>
+        </p:spPr>
+        <p:txBody>
+          <a:bodyPr wrap="square" lIns="0" rIns="0" tIns="0" bIns="0" anchor="ctr">
+            <a:spAutoFit/>
+          </a:bodyPr>
+          <a:lstStyle/>
+          <a:p>
+            <a:pPr algn="ctr">
+              <a:lnSpc>
+                <a:spcPts val="1600"/>
+              </a:lnSpc>
+              <a:spcAft>
+                <a:spcPts val="0"/>
+              </a:spcAft>
+            </a:pPr>
+            <a:r>
+              <a:rPr sz="1350" b="1" i="0">
+                <a:solidFill>
+                  <a:srgbClr val="1F5673"/>
+                </a:solidFill>
+                <a:latin typeface="Calibri"/>
+              </a:rPr>
+              <a:t>Run the model</a:t>
+            </a:r>
+          </a:p>
+        </p:txBody>
+      </p:sp>
+      <p:sp>
+        <p:nvSpPr>
+          <p:cNvPr id="19" name="Right Arrow 18"/>
+          <p:cNvSpPr/>
+          <p:nvPr/>
+        </p:nvSpPr>
+        <p:spPr>
+          <a:xfrm>
+            <a:off x="9717786" y="2327148"/>
+            <a:ext cx="274320" cy="237744"/>
+          </a:xfrm>
+          <a:prstGeom prst="rightArrow">
+            <a:avLst/>
+          </a:prstGeom>
+          <a:solidFill>
+            <a:srgbClr val="8DB0C4"/>
+          </a:solidFill>
+          <a:ln>
+            <a:noFill/>
+          </a:ln>
+          <a:effectLst/>
+        </p:spPr>
+        <p:style>
+          <a:lnRef idx="1">
+            <a:schemeClr val="accent1"/>
+          </a:lnRef>
+          <a:fillRef idx="3">
+            <a:schemeClr val="accent1"/>
+          </a:fillRef>
+          <a:effectRef idx="2">
+            <a:schemeClr val="accent1"/>
+          </a:effectRef>
+          <a:fontRef idx="minor">
+            <a:schemeClr val="lt1"/>
+          </a:fontRef>
+        </p:style>
+        <p:txBody>
+          <a:bodyPr rtlCol="0" anchor="ctr"/>
+          <a:lstStyle/>
+          <a:p>
+            <a:pPr algn="ctr"/>
+          </a:p>
+        </p:txBody>
+      </p:sp>
+      <p:sp>
+        <p:nvSpPr>
+          <p:cNvPr id="20" name="Rounded Rectangle 19"/>
+          <p:cNvSpPr/>
+          <p:nvPr/>
+        </p:nvSpPr>
+        <p:spPr>
+          <a:xfrm>
+            <a:off x="10037826" y="2057400"/>
+            <a:ext cx="1513789" cy="777240"/>
+          </a:xfrm>
+          <a:prstGeom prst="roundRect">
+            <a:avLst>
+              <a:gd name="adj" fmla="val 12000"/>
+            </a:avLst>
+          </a:prstGeom>
+          <a:solidFill>
+            <a:srgbClr val="EAF0F4"/>
+          </a:solidFill>
+          <a:ln>
+            <a:noFill/>
+          </a:ln>
+          <a:effectLst/>
+        </p:spPr>
+        <p:style>
+          <a:lnRef idx="1">
+            <a:schemeClr val="accent1"/>
+          </a:lnRef>
+          <a:fillRef idx="3">
+            <a:schemeClr val="accent1"/>
+          </a:fillRef>
+          <a:effectRef idx="2">
+            <a:schemeClr val="accent1"/>
+          </a:effectRef>
+          <a:fontRef idx="minor">
+            <a:schemeClr val="lt1"/>
+          </a:fontRef>
+        </p:style>
+        <p:txBody>
+          <a:bodyPr rtlCol="0" anchor="ctr"/>
+          <a:lstStyle/>
+          <a:p>
+            <a:pPr algn="ctr"/>
+          </a:p>
+        </p:txBody>
+      </p:sp>
+      <p:sp>
+        <p:nvSpPr>
+          <p:cNvPr id="21" name="TextBox 20"/>
+          <p:cNvSpPr txBox="1"/>
+          <p:nvPr/>
+        </p:nvSpPr>
+        <p:spPr>
+          <a:xfrm>
+            <a:off x="10129265" y="2057400"/>
+            <a:ext cx="1330909" cy="777240"/>
+          </a:xfrm>
+          <a:prstGeom prst="rect">
+            <a:avLst/>
+          </a:prstGeom>
+          <a:noFill/>
+        </p:spPr>
+        <p:txBody>
+          <a:bodyPr wrap="square" lIns="0" rIns="0" tIns="0" bIns="0" anchor="ctr">
+            <a:spAutoFit/>
+          </a:bodyPr>
+          <a:lstStyle/>
+          <a:p>
+            <a:pPr algn="ctr">
+              <a:lnSpc>
+                <a:spcPts val="1600"/>
+              </a:lnSpc>
+              <a:spcAft>
+                <a:spcPts val="0"/>
+              </a:spcAft>
+            </a:pPr>
+            <a:r>
+              <a:rPr sz="1350" b="1" i="0">
+                <a:solidFill>
+                  <a:srgbClr val="1F5673"/>
+                </a:solidFill>
+                <a:latin typeface="Calibri"/>
+              </a:rPr>
+              <a:t>Read the results</a:t>
+            </a:r>
+          </a:p>
+        </p:txBody>
+      </p:sp>
+      <p:sp>
+        <p:nvSpPr>
+          <p:cNvPr id="22" name="TextBox 21"/>
+          <p:cNvSpPr txBox="1"/>
+          <p:nvPr/>
+        </p:nvSpPr>
+        <p:spPr>
+          <a:xfrm>
+            <a:off x="640080" y="3154680"/>
+            <a:ext cx="10911535" cy="274320"/>
+          </a:xfrm>
+          <a:prstGeom prst="rect">
+            <a:avLst/>
+          </a:prstGeom>
+          <a:noFill/>
+        </p:spPr>
+        <p:txBody>
+          <a:bodyPr wrap="square" lIns="0" rIns="0" tIns="0" bIns="0" anchor="t">
+            <a:spAutoFit/>
+          </a:bodyPr>
+          <a:lstStyle/>
+          <a:p>
             <a:pPr algn="l">
               <a:lnSpc>
-                <a:spcPts val="2000"/>
+                <a:spcPts val="1689"/>
+              </a:lnSpc>
+              <a:spcAft>
+                <a:spcPts val="0"/>
+              </a:spcAft>
+            </a:pPr>
+            <a:r>
+              <a:rPr sz="1350" b="1" i="0">
+                <a:solidFill>
+                  <a:srgbClr val="5B6770"/>
+                </a:solidFill>
+                <a:latin typeface="Calibri"/>
+              </a:rPr>
+              <a:t>For each step we ask</a:t>
+            </a:r>
+          </a:p>
+        </p:txBody>
+      </p:sp>
+      <p:sp>
+        <p:nvSpPr>
+          <p:cNvPr id="23" name="Oval 22"/>
+          <p:cNvSpPr/>
+          <p:nvPr/>
+        </p:nvSpPr>
+        <p:spPr>
+          <a:xfrm>
+            <a:off x="640080" y="3538728"/>
+            <a:ext cx="310896" cy="310896"/>
+          </a:xfrm>
+          <a:prstGeom prst="ellipse">
+            <a:avLst/>
+          </a:prstGeom>
+          <a:solidFill>
+            <a:srgbClr val="1F5673"/>
+          </a:solidFill>
+          <a:ln>
+            <a:noFill/>
+          </a:ln>
+          <a:effectLst/>
+        </p:spPr>
+        <p:style>
+          <a:lnRef idx="1">
+            <a:schemeClr val="accent1"/>
+          </a:lnRef>
+          <a:fillRef idx="3">
+            <a:schemeClr val="accent1"/>
+          </a:fillRef>
+          <a:effectRef idx="2">
+            <a:schemeClr val="accent1"/>
+          </a:effectRef>
+          <a:fontRef idx="minor">
+            <a:schemeClr val="lt1"/>
+          </a:fontRef>
+        </p:style>
+        <p:txBody>
+          <a:bodyPr rtlCol="0" anchor="ctr" lIns="0" rIns="0" tIns="0" bIns="0" wrap="none"/>
+          <a:lstStyle/>
+          <a:p>
+            <a:pPr algn="ctr"/>
+            <a:r>
+              <a:rPr sz="1200" b="1">
+                <a:solidFill>
+                  <a:srgbClr val="FFFFFF"/>
+                </a:solidFill>
+                <a:latin typeface="Calibri"/>
+              </a:rPr>
+              <a:t>1</a:t>
+            </a:r>
+          </a:p>
+        </p:txBody>
+      </p:sp>
+      <p:sp>
+        <p:nvSpPr>
+          <p:cNvPr id="24" name="TextBox 23"/>
+          <p:cNvSpPr txBox="1"/>
+          <p:nvPr/>
+        </p:nvSpPr>
+        <p:spPr>
+          <a:xfrm>
+            <a:off x="1097280" y="3520440"/>
+            <a:ext cx="2064943" cy="685800"/>
+          </a:xfrm>
+          <a:prstGeom prst="rect">
+            <a:avLst/>
+          </a:prstGeom>
+          <a:noFill/>
+        </p:spPr>
+        <p:txBody>
+          <a:bodyPr wrap="square" lIns="0" rIns="0" tIns="0" bIns="0" anchor="t">
+            <a:spAutoFit/>
+          </a:bodyPr>
+          <a:lstStyle/>
+          <a:p>
+            <a:pPr algn="l">
+              <a:lnSpc>
+                <a:spcPts val="1650"/>
+              </a:lnSpc>
+              <a:spcAft>
+                <a:spcPts val="200"/>
+              </a:spcAft>
+            </a:pPr>
+            <a:r>
+              <a:rPr sz="1300" b="1" i="0">
+                <a:solidFill>
+                  <a:srgbClr val="1F2A30"/>
+                </a:solidFill>
+                <a:latin typeface="Calibri"/>
+              </a:rPr>
+              <a:t>What happens today</a:t>
+            </a:r>
+          </a:p>
+          <a:p>
+            <a:pPr algn="l">
+              <a:lnSpc>
+                <a:spcPts val="1650"/>
               </a:lnSpc>
               <a:spcAft>
                 <a:spcPts val="600"/>
               </a:spcAft>
             </a:pPr>
             <a:r>
-              <a:rPr sz="1600" b="1" i="0">
-                <a:solidFill>
-                  <a:srgbClr val="9C5214"/>
-                </a:solidFill>
-                <a:latin typeface="Calibri"/>
-              </a:rPr>
-              <a:t>In the works</a:t>
-            </a:r>
-          </a:p>
+              <a:rPr sz="1300" b="0" i="0">
+                <a:solidFill>
+                  <a:srgbClr val="5B6770"/>
+                </a:solidFill>
+                <a:latin typeface="Calibri"/>
+              </a:rPr>
+              <a:t>The step as the modellers do it now.</a:t>
+            </a:r>
+          </a:p>
+        </p:txBody>
+      </p:sp>
+      <p:sp>
+        <p:nvSpPr>
+          <p:cNvPr id="25" name="Oval 24"/>
+          <p:cNvSpPr/>
+          <p:nvPr/>
+        </p:nvSpPr>
+        <p:spPr>
+          <a:xfrm>
+            <a:off x="3436543" y="3538728"/>
+            <a:ext cx="310896" cy="310896"/>
+          </a:xfrm>
+          <a:prstGeom prst="ellipse">
+            <a:avLst/>
+          </a:prstGeom>
+          <a:solidFill>
+            <a:srgbClr val="1F5673"/>
+          </a:solidFill>
+          <a:ln>
+            <a:noFill/>
+          </a:ln>
+          <a:effectLst/>
+        </p:spPr>
+        <p:style>
+          <a:lnRef idx="1">
+            <a:schemeClr val="accent1"/>
+          </a:lnRef>
+          <a:fillRef idx="3">
+            <a:schemeClr val="accent1"/>
+          </a:fillRef>
+          <a:effectRef idx="2">
+            <a:schemeClr val="accent1"/>
+          </a:effectRef>
+          <a:fontRef idx="minor">
+            <a:schemeClr val="lt1"/>
+          </a:fontRef>
+        </p:style>
+        <p:txBody>
+          <a:bodyPr rtlCol="0" anchor="ctr" lIns="0" rIns="0" tIns="0" bIns="0" wrap="none"/>
+          <a:lstStyle/>
+          <a:p>
+            <a:pPr algn="ctr"/>
+            <a:r>
+              <a:rPr sz="1200" b="1">
+                <a:solidFill>
+                  <a:srgbClr val="FFFFFF"/>
+                </a:solidFill>
+                <a:latin typeface="Calibri"/>
+              </a:rPr>
+              <a:t>2</a:t>
+            </a:r>
+          </a:p>
+        </p:txBody>
+      </p:sp>
+      <p:sp>
+        <p:nvSpPr>
+          <p:cNvPr id="26" name="TextBox 25"/>
+          <p:cNvSpPr txBox="1"/>
+          <p:nvPr/>
+        </p:nvSpPr>
+        <p:spPr>
+          <a:xfrm>
+            <a:off x="3893743" y="3520440"/>
+            <a:ext cx="2064943" cy="685800"/>
+          </a:xfrm>
+          <a:prstGeom prst="rect">
+            <a:avLst/>
+          </a:prstGeom>
+          <a:noFill/>
+        </p:spPr>
+        <p:txBody>
+          <a:bodyPr wrap="square" lIns="0" rIns="0" tIns="0" bIns="0" anchor="t">
+            <a:spAutoFit/>
+          </a:bodyPr>
+          <a:lstStyle/>
           <a:p>
             <a:pPr algn="l">
               <a:lnSpc>
-                <a:spcPts val="2000"/>
+                <a:spcPts val="1650"/>
+              </a:lnSpc>
+              <a:spcAft>
+                <a:spcPts val="200"/>
+              </a:spcAft>
+            </a:pPr>
+            <a:r>
+              <a:rPr sz="1300" b="1" i="0">
+                <a:solidFill>
+                  <a:srgbClr val="1F2A30"/>
+                </a:solidFill>
+                <a:latin typeface="Calibri"/>
+              </a:rPr>
+              <a:t>What the step needs</a:t>
+            </a:r>
+          </a:p>
+          <a:p>
+            <a:pPr algn="l">
+              <a:lnSpc>
+                <a:spcPts val="1650"/>
               </a:lnSpc>
               <a:spcAft>
                 <a:spcPts val="600"/>
               </a:spcAft>
             </a:pPr>
             <a:r>
-              <a:rPr sz="1450" b="0" i="0">
+              <a:rPr sz="1300" b="0" i="0">
+                <a:solidFill>
+                  <a:srgbClr val="5B6770"/>
+                </a:solidFill>
+                <a:latin typeface="Calibri"/>
+              </a:rPr>
+              <a:t>Reading, arithmetic, judgment or checking.</a:t>
+            </a:r>
+          </a:p>
+        </p:txBody>
+      </p:sp>
+      <p:sp>
+        <p:nvSpPr>
+          <p:cNvPr id="27" name="Oval 26"/>
+          <p:cNvSpPr/>
+          <p:nvPr/>
+        </p:nvSpPr>
+        <p:spPr>
+          <a:xfrm>
+            <a:off x="6233007" y="3538728"/>
+            <a:ext cx="310896" cy="310896"/>
+          </a:xfrm>
+          <a:prstGeom prst="ellipse">
+            <a:avLst/>
+          </a:prstGeom>
+          <a:solidFill>
+            <a:srgbClr val="1F5673"/>
+          </a:solidFill>
+          <a:ln>
+            <a:noFill/>
+          </a:ln>
+          <a:effectLst/>
+        </p:spPr>
+        <p:style>
+          <a:lnRef idx="1">
+            <a:schemeClr val="accent1"/>
+          </a:lnRef>
+          <a:fillRef idx="3">
+            <a:schemeClr val="accent1"/>
+          </a:fillRef>
+          <a:effectRef idx="2">
+            <a:schemeClr val="accent1"/>
+          </a:effectRef>
+          <a:fontRef idx="minor">
+            <a:schemeClr val="lt1"/>
+          </a:fontRef>
+        </p:style>
+        <p:txBody>
+          <a:bodyPr rtlCol="0" anchor="ctr" lIns="0" rIns="0" tIns="0" bIns="0" wrap="none"/>
+          <a:lstStyle/>
+          <a:p>
+            <a:pPr algn="ctr"/>
+            <a:r>
+              <a:rPr sz="1200" b="1">
+                <a:solidFill>
+                  <a:srgbClr val="FFFFFF"/>
+                </a:solidFill>
+                <a:latin typeface="Calibri"/>
+              </a:rPr>
+              <a:t>3</a:t>
+            </a:r>
+          </a:p>
+        </p:txBody>
+      </p:sp>
+      <p:sp>
+        <p:nvSpPr>
+          <p:cNvPr id="28" name="TextBox 27"/>
+          <p:cNvSpPr txBox="1"/>
+          <p:nvPr/>
+        </p:nvSpPr>
+        <p:spPr>
+          <a:xfrm>
+            <a:off x="6690207" y="3520440"/>
+            <a:ext cx="2064943" cy="685800"/>
+          </a:xfrm>
+          <a:prstGeom prst="rect">
+            <a:avLst/>
+          </a:prstGeom>
+          <a:noFill/>
+        </p:spPr>
+        <p:txBody>
+          <a:bodyPr wrap="square" lIns="0" rIns="0" tIns="0" bIns="0" anchor="t">
+            <a:spAutoFit/>
+          </a:bodyPr>
+          <a:lstStyle/>
+          <a:p>
+            <a:pPr algn="l">
+              <a:lnSpc>
+                <a:spcPts val="1650"/>
+              </a:lnSpc>
+              <a:spcAft>
+                <a:spcPts val="200"/>
+              </a:spcAft>
+            </a:pPr>
+            <a:r>
+              <a:rPr sz="1300" b="1" i="0">
                 <a:solidFill>
                   <a:srgbClr val="1F2A30"/>
                 </a:solidFill>
                 <a:latin typeface="Calibri"/>
               </a:rPr>
-              <a:t>We are still working out how to approach this chapter, and want a bit more time with it before we settle on anything.</a:t>
+              <a:t>What an agent could do</a:t>
+            </a:r>
+          </a:p>
+          <a:p>
+            <a:pPr algn="l">
+              <a:lnSpc>
+                <a:spcPts val="1650"/>
+              </a:lnSpc>
+              <a:spcAft>
+                <a:spcPts val="600"/>
+              </a:spcAft>
+            </a:pPr>
+            <a:r>
+              <a:rPr sz="1300" b="0" i="0">
+                <a:solidFill>
+                  <a:srgbClr val="5B6770"/>
+                </a:solidFill>
+                <a:latin typeface="Calibri"/>
+              </a:rPr>
+              <a:t>Using what we set out in chapter 4.</a:t>
+            </a:r>
+          </a:p>
+        </p:txBody>
+      </p:sp>
+      <p:sp>
+        <p:nvSpPr>
+          <p:cNvPr id="29" name="Oval 28"/>
+          <p:cNvSpPr/>
+          <p:nvPr/>
+        </p:nvSpPr>
+        <p:spPr>
+          <a:xfrm>
+            <a:off x="9029471" y="3538728"/>
+            <a:ext cx="310896" cy="310896"/>
+          </a:xfrm>
+          <a:prstGeom prst="ellipse">
+            <a:avLst/>
+          </a:prstGeom>
+          <a:solidFill>
+            <a:srgbClr val="1F5673"/>
+          </a:solidFill>
+          <a:ln>
+            <a:noFill/>
+          </a:ln>
+          <a:effectLst/>
+        </p:spPr>
+        <p:style>
+          <a:lnRef idx="1">
+            <a:schemeClr val="accent1"/>
+          </a:lnRef>
+          <a:fillRef idx="3">
+            <a:schemeClr val="accent1"/>
+          </a:fillRef>
+          <a:effectRef idx="2">
+            <a:schemeClr val="accent1"/>
+          </a:effectRef>
+          <a:fontRef idx="minor">
+            <a:schemeClr val="lt1"/>
+          </a:fontRef>
+        </p:style>
+        <p:txBody>
+          <a:bodyPr rtlCol="0" anchor="ctr" lIns="0" rIns="0" tIns="0" bIns="0" wrap="none"/>
+          <a:lstStyle/>
+          <a:p>
+            <a:pPr algn="ctr"/>
+            <a:r>
+              <a:rPr sz="1200" b="1">
+                <a:solidFill>
+                  <a:srgbClr val="FFFFFF"/>
+                </a:solidFill>
+                <a:latin typeface="Calibri"/>
+              </a:rPr>
+              <a:t>4</a:t>
+            </a:r>
+          </a:p>
+        </p:txBody>
+      </p:sp>
+      <p:sp>
+        <p:nvSpPr>
+          <p:cNvPr id="30" name="TextBox 29"/>
+          <p:cNvSpPr txBox="1"/>
+          <p:nvPr/>
+        </p:nvSpPr>
+        <p:spPr>
+          <a:xfrm>
+            <a:off x="9486671" y="3520440"/>
+            <a:ext cx="2064943" cy="685800"/>
+          </a:xfrm>
+          <a:prstGeom prst="rect">
+            <a:avLst/>
+          </a:prstGeom>
+          <a:noFill/>
+        </p:spPr>
+        <p:txBody>
+          <a:bodyPr wrap="square" lIns="0" rIns="0" tIns="0" bIns="0" anchor="t">
+            <a:spAutoFit/>
+          </a:bodyPr>
+          <a:lstStyle/>
+          <a:p>
+            <a:pPr algn="l">
+              <a:lnSpc>
+                <a:spcPts val="1650"/>
+              </a:lnSpc>
+              <a:spcAft>
+                <a:spcPts val="200"/>
+              </a:spcAft>
+            </a:pPr>
+            <a:r>
+              <a:rPr sz="1300" b="1" i="0">
+                <a:solidFill>
+                  <a:srgbClr val="1F2A30"/>
+                </a:solidFill>
+                <a:latin typeface="Calibri"/>
+              </a:rPr>
+              <a:t>Where a person stays involved</a:t>
+            </a:r>
+          </a:p>
+          <a:p>
+            <a:pPr algn="l">
+              <a:lnSpc>
+                <a:spcPts val="1650"/>
+              </a:lnSpc>
+              <a:spcAft>
+                <a:spcPts val="600"/>
+              </a:spcAft>
+            </a:pPr>
+            <a:r>
+              <a:rPr sz="1300" b="0" i="0">
+                <a:solidFill>
+                  <a:srgbClr val="5B6770"/>
+                </a:solidFill>
+                <a:latin typeface="Calibri"/>
+              </a:rPr>
+              <a:t>Judgment calls and sign-offs.</a:t>
+            </a:r>
+          </a:p>
+        </p:txBody>
+      </p:sp>
+      <p:sp>
+        <p:nvSpPr>
+          <p:cNvPr id="31" name="TextBox 30"/>
+          <p:cNvSpPr txBox="1"/>
+          <p:nvPr/>
+        </p:nvSpPr>
+        <p:spPr>
+          <a:xfrm>
+            <a:off x="640080" y="4526280"/>
+            <a:ext cx="10911535" cy="274320"/>
+          </a:xfrm>
+          <a:prstGeom prst="rect">
+            <a:avLst/>
+          </a:prstGeom>
+          <a:noFill/>
+        </p:spPr>
+        <p:txBody>
+          <a:bodyPr wrap="square" lIns="0" rIns="0" tIns="0" bIns="0" anchor="t">
+            <a:spAutoFit/>
+          </a:bodyPr>
+          <a:lstStyle/>
+          <a:p>
+            <a:pPr algn="l">
+              <a:lnSpc>
+                <a:spcPts val="1689"/>
+              </a:lnSpc>
+              <a:spcAft>
+                <a:spcPts val="0"/>
+              </a:spcAft>
+            </a:pPr>
+            <a:r>
+              <a:rPr sz="1350" b="1" i="0">
+                <a:solidFill>
+                  <a:srgbClr val="5B6770"/>
+                </a:solidFill>
+                <a:latin typeface="Calibri"/>
+              </a:rPr>
+              <a:t>Along the way and at the end</a:t>
+            </a:r>
+          </a:p>
+        </p:txBody>
+      </p:sp>
+      <p:sp>
+        <p:nvSpPr>
+          <p:cNvPr id="32" name="Rounded Rectangle 31"/>
+          <p:cNvSpPr/>
+          <p:nvPr/>
+        </p:nvSpPr>
+        <p:spPr>
+          <a:xfrm>
+            <a:off x="640080" y="4846320"/>
+            <a:ext cx="3454298" cy="1371600"/>
+          </a:xfrm>
+          <a:prstGeom prst="roundRect">
+            <a:avLst>
+              <a:gd name="adj" fmla="val 6000"/>
+            </a:avLst>
+          </a:prstGeom>
+          <a:solidFill>
+            <a:srgbClr val="EAF0F4"/>
+          </a:solidFill>
+          <a:ln>
+            <a:noFill/>
+          </a:ln>
+          <a:effectLst/>
+        </p:spPr>
+        <p:style>
+          <a:lnRef idx="1">
+            <a:schemeClr val="accent1"/>
+          </a:lnRef>
+          <a:fillRef idx="3">
+            <a:schemeClr val="accent1"/>
+          </a:fillRef>
+          <a:effectRef idx="2">
+            <a:schemeClr val="accent1"/>
+          </a:effectRef>
+          <a:fontRef idx="minor">
+            <a:schemeClr val="lt1"/>
+          </a:fontRef>
+        </p:style>
+        <p:txBody>
+          <a:bodyPr rtlCol="0" anchor="ctr"/>
+          <a:lstStyle/>
+          <a:p>
+            <a:pPr algn="ctr"/>
+          </a:p>
+        </p:txBody>
+      </p:sp>
+      <p:sp>
+        <p:nvSpPr>
+          <p:cNvPr id="33" name="TextBox 32"/>
+          <p:cNvSpPr txBox="1"/>
+          <p:nvPr/>
+        </p:nvSpPr>
+        <p:spPr>
+          <a:xfrm>
+            <a:off x="914400" y="4983480"/>
+            <a:ext cx="2905658" cy="292608"/>
+          </a:xfrm>
+          <a:prstGeom prst="rect">
+            <a:avLst/>
+          </a:prstGeom>
+          <a:noFill/>
+        </p:spPr>
+        <p:txBody>
+          <a:bodyPr wrap="square" lIns="0" rIns="0" tIns="0" bIns="0" anchor="t">
+            <a:spAutoFit/>
+          </a:bodyPr>
+          <a:lstStyle/>
+          <a:p>
+            <a:pPr algn="l">
+              <a:lnSpc>
+                <a:spcPts val="1810"/>
+              </a:lnSpc>
+              <a:spcAft>
+                <a:spcPts val="0"/>
+              </a:spcAft>
+            </a:pPr>
+            <a:r>
+              <a:rPr sz="1450" b="1" i="0">
+                <a:solidFill>
+                  <a:srgbClr val="1F5673"/>
+                </a:solidFill>
+                <a:latin typeface="Calibri"/>
+              </a:rPr>
+              <a:t>Examples from real data</a:t>
+            </a:r>
+          </a:p>
+        </p:txBody>
+      </p:sp>
+      <p:sp>
+        <p:nvSpPr>
+          <p:cNvPr id="34" name="TextBox 33"/>
+          <p:cNvSpPr txBox="1"/>
+          <p:nvPr/>
+        </p:nvSpPr>
+        <p:spPr>
+          <a:xfrm>
+            <a:off x="914400" y="5349240"/>
+            <a:ext cx="2905658" cy="777240"/>
+          </a:xfrm>
+          <a:prstGeom prst="rect">
+            <a:avLst/>
+          </a:prstGeom>
+          <a:noFill/>
+        </p:spPr>
+        <p:txBody>
+          <a:bodyPr wrap="square" lIns="0" rIns="0" tIns="0" bIns="0" anchor="t">
+            <a:spAutoFit/>
+          </a:bodyPr>
+          <a:lstStyle/>
+          <a:p>
+            <a:pPr algn="l">
+              <a:lnSpc>
+                <a:spcPts val="1600"/>
+              </a:lnSpc>
+              <a:spcAft>
+                <a:spcPts val="600"/>
+              </a:spcAft>
+            </a:pPr>
+            <a:r>
+              <a:rPr sz="1250" b="0" i="0">
+                <a:solidFill>
+                  <a:srgbClr val="1F2A30"/>
+                </a:solidFill>
+                <a:latin typeface="Calibri"/>
+              </a:rPr>
+              <a:t>Short examples from the 2023 data back up the points, so the chapter stays general without being vague.</a:t>
+            </a:r>
+          </a:p>
+        </p:txBody>
+      </p:sp>
+      <p:sp>
+        <p:nvSpPr>
+          <p:cNvPr id="35" name="Rounded Rectangle 34"/>
+          <p:cNvSpPr/>
+          <p:nvPr/>
+        </p:nvSpPr>
+        <p:spPr>
+          <a:xfrm>
+            <a:off x="4368698" y="4846320"/>
+            <a:ext cx="3454298" cy="1371600"/>
+          </a:xfrm>
+          <a:prstGeom prst="roundRect">
+            <a:avLst>
+              <a:gd name="adj" fmla="val 6000"/>
+            </a:avLst>
+          </a:prstGeom>
+          <a:solidFill>
+            <a:srgbClr val="EAF0F4"/>
+          </a:solidFill>
+          <a:ln>
+            <a:noFill/>
+          </a:ln>
+          <a:effectLst/>
+        </p:spPr>
+        <p:style>
+          <a:lnRef idx="1">
+            <a:schemeClr val="accent1"/>
+          </a:lnRef>
+          <a:fillRef idx="3">
+            <a:schemeClr val="accent1"/>
+          </a:fillRef>
+          <a:effectRef idx="2">
+            <a:schemeClr val="accent1"/>
+          </a:effectRef>
+          <a:fontRef idx="minor">
+            <a:schemeClr val="lt1"/>
+          </a:fontRef>
+        </p:style>
+        <p:txBody>
+          <a:bodyPr rtlCol="0" anchor="ctr"/>
+          <a:lstStyle/>
+          <a:p>
+            <a:pPr algn="ctr"/>
+          </a:p>
+        </p:txBody>
+      </p:sp>
+      <p:sp>
+        <p:nvSpPr>
+          <p:cNvPr id="36" name="TextBox 35"/>
+          <p:cNvSpPr txBox="1"/>
+          <p:nvPr/>
+        </p:nvSpPr>
+        <p:spPr>
+          <a:xfrm>
+            <a:off x="4643018" y="4983480"/>
+            <a:ext cx="2905658" cy="292608"/>
+          </a:xfrm>
+          <a:prstGeom prst="rect">
+            <a:avLst/>
+          </a:prstGeom>
+          <a:noFill/>
+        </p:spPr>
+        <p:txBody>
+          <a:bodyPr wrap="square" lIns="0" rIns="0" tIns="0" bIns="0" anchor="t">
+            <a:spAutoFit/>
+          </a:bodyPr>
+          <a:lstStyle/>
+          <a:p>
+            <a:pPr algn="l">
+              <a:lnSpc>
+                <a:spcPts val="1810"/>
+              </a:lnSpc>
+              <a:spcAft>
+                <a:spcPts val="0"/>
+              </a:spcAft>
+            </a:pPr>
+            <a:r>
+              <a:rPr sz="1450" b="1" i="0">
+                <a:solidFill>
+                  <a:srgbClr val="1F5673"/>
+                </a:solidFill>
+                <a:latin typeface="Calibri"/>
+              </a:rPr>
+              <a:t>A figure that sums it up</a:t>
+            </a:r>
+          </a:p>
+        </p:txBody>
+      </p:sp>
+      <p:sp>
+        <p:nvSpPr>
+          <p:cNvPr id="37" name="TextBox 36"/>
+          <p:cNvSpPr txBox="1"/>
+          <p:nvPr/>
+        </p:nvSpPr>
+        <p:spPr>
+          <a:xfrm>
+            <a:off x="4643018" y="5349240"/>
+            <a:ext cx="2905658" cy="777240"/>
+          </a:xfrm>
+          <a:prstGeom prst="rect">
+            <a:avLst/>
+          </a:prstGeom>
+          <a:noFill/>
+        </p:spPr>
+        <p:txBody>
+          <a:bodyPr wrap="square" lIns="0" rIns="0" tIns="0" bIns="0" anchor="t">
+            <a:spAutoFit/>
+          </a:bodyPr>
+          <a:lstStyle/>
+          <a:p>
+            <a:pPr algn="l">
+              <a:lnSpc>
+                <a:spcPts val="1600"/>
+              </a:lnSpc>
+              <a:spcAft>
+                <a:spcPts val="600"/>
+              </a:spcAft>
+            </a:pPr>
+            <a:r>
+              <a:rPr sz="1250" b="0" i="0">
+                <a:solidFill>
+                  <a:srgbClr val="1F2A30"/>
+                </a:solidFill>
+                <a:latin typeface="Calibri"/>
+              </a:rPr>
+              <a:t>Where each step lands, from “automate” to “keep with a person”. We haven't settled the format yet.</a:t>
+            </a:r>
+          </a:p>
+        </p:txBody>
+      </p:sp>
+      <p:sp>
+        <p:nvSpPr>
+          <p:cNvPr id="38" name="Rounded Rectangle 37"/>
+          <p:cNvSpPr/>
+          <p:nvPr/>
+        </p:nvSpPr>
+        <p:spPr>
+          <a:xfrm>
+            <a:off x="8097316" y="4846320"/>
+            <a:ext cx="3454298" cy="1371600"/>
+          </a:xfrm>
+          <a:prstGeom prst="roundRect">
+            <a:avLst>
+              <a:gd name="adj" fmla="val 6000"/>
+            </a:avLst>
+          </a:prstGeom>
+          <a:solidFill>
+            <a:srgbClr val="FBEEDD"/>
+          </a:solidFill>
+          <a:ln>
+            <a:noFill/>
+          </a:ln>
+          <a:effectLst/>
+        </p:spPr>
+        <p:style>
+          <a:lnRef idx="1">
+            <a:schemeClr val="accent1"/>
+          </a:lnRef>
+          <a:fillRef idx="3">
+            <a:schemeClr val="accent1"/>
+          </a:fillRef>
+          <a:effectRef idx="2">
+            <a:schemeClr val="accent1"/>
+          </a:effectRef>
+          <a:fontRef idx="minor">
+            <a:schemeClr val="lt1"/>
+          </a:fontRef>
+        </p:style>
+        <p:txBody>
+          <a:bodyPr rtlCol="0" anchor="ctr"/>
+          <a:lstStyle/>
+          <a:p>
+            <a:pPr algn="ctr"/>
+          </a:p>
+        </p:txBody>
+      </p:sp>
+      <p:sp>
+        <p:nvSpPr>
+          <p:cNvPr id="39" name="TextBox 38"/>
+          <p:cNvSpPr txBox="1"/>
+          <p:nvPr/>
+        </p:nvSpPr>
+        <p:spPr>
+          <a:xfrm>
+            <a:off x="8371636" y="4983480"/>
+            <a:ext cx="2905658" cy="292608"/>
+          </a:xfrm>
+          <a:prstGeom prst="rect">
+            <a:avLst/>
+          </a:prstGeom>
+          <a:noFill/>
+        </p:spPr>
+        <p:txBody>
+          <a:bodyPr wrap="square" lIns="0" rIns="0" tIns="0" bIns="0" anchor="t">
+            <a:spAutoFit/>
+          </a:bodyPr>
+          <a:lstStyle/>
+          <a:p>
+            <a:pPr algn="l">
+              <a:lnSpc>
+                <a:spcPts val="1810"/>
+              </a:lnSpc>
+              <a:spcAft>
+                <a:spcPts val="0"/>
+              </a:spcAft>
+            </a:pPr>
+            <a:r>
+              <a:rPr sz="1450" b="1" i="0">
+                <a:solidFill>
+                  <a:srgbClr val="9C5214"/>
+                </a:solidFill>
+                <a:latin typeface="Calibri"/>
+              </a:rPr>
+              <a:t>A job description for each agent</a:t>
+            </a:r>
+          </a:p>
+        </p:txBody>
+      </p:sp>
+      <p:sp>
+        <p:nvSpPr>
+          <p:cNvPr id="40" name="TextBox 39"/>
+          <p:cNvSpPr txBox="1"/>
+          <p:nvPr/>
+        </p:nvSpPr>
+        <p:spPr>
+          <a:xfrm>
+            <a:off x="8371636" y="5349240"/>
+            <a:ext cx="2905658" cy="777240"/>
+          </a:xfrm>
+          <a:prstGeom prst="rect">
+            <a:avLst/>
+          </a:prstGeom>
+          <a:noFill/>
+        </p:spPr>
+        <p:txBody>
+          <a:bodyPr wrap="square" lIns="0" rIns="0" tIns="0" bIns="0" anchor="t">
+            <a:spAutoFit/>
+          </a:bodyPr>
+          <a:lstStyle/>
+          <a:p>
+            <a:pPr algn="l">
+              <a:lnSpc>
+                <a:spcPts val="1600"/>
+              </a:lnSpc>
+              <a:spcAft>
+                <a:spcPts val="600"/>
+              </a:spcAft>
+            </a:pPr>
+            <a:r>
+              <a:rPr sz="1250" b="0" i="0">
+                <a:solidFill>
+                  <a:srgbClr val="1F2A30"/>
+                </a:solidFill>
+                <a:latin typeface="Calibri"/>
+              </a:rPr>
+              <a:t>What each agent gets, what it produces and what it must not do. This is where next semester starts.</a:t>
             </a:r>
           </a:p>
         </p:txBody>

</xml_diff>